<commit_message>
Styled presentation generator: nav bar and results slide design
</commit_message>
<xml_diff>
--- a/Aziz_Presentation.pptx
+++ b/Aziz_Presentation.pptx
@@ -7,14 +7,6 @@
   <p:sldIdLst>
     <p:sldId id="256" r:id="rId7"/>
     <p:sldId id="257" r:id="rId8"/>
-    <p:sldId id="258" r:id="rId9"/>
-    <p:sldId id="259" r:id="rId10"/>
-    <p:sldId id="260" r:id="rId11"/>
-    <p:sldId id="261" r:id="rId12"/>
-    <p:sldId id="262" r:id="rId13"/>
-    <p:sldId id="263" r:id="rId14"/>
-    <p:sldId id="264" r:id="rId15"/>
-    <p:sldId id="265" r:id="rId16"/>
   </p:sldIdLst>
   <p:sldSz cx="9144000" cy="6858000" type="screen4x3"/>
   <p:notesSz cx="6858000" cy="9144000"/>
@@ -3104,7 +3096,7 @@
             <a:spLocks noGrp="1"/>
           </p:cNvSpPr>
           <p:nvPr>
-            <p:ph type="title"/>
+            <p:ph type="ctrTitle"/>
           </p:nvPr>
         </p:nvSpPr>
         <p:spPr/>
@@ -3120,12 +3112,12 @@
       </p:sp>
       <p:sp>
         <p:nvSpPr>
-          <p:cNvPr id="3" name="Content Placeholder 2"/>
-          <p:cNvSpPr>
-            <a:spLocks noGrp="1"/>
-          </p:cNvSpPr>
-          <p:nvPr>
-            <p:ph idx="1"/>
+          <p:cNvPr id="3" name="Subtitle 2"/>
+          <p:cNvSpPr>
+            <a:spLocks noGrp="1"/>
+          </p:cNvSpPr>
+          <p:nvPr>
+            <p:ph type="subTitle" idx="1"/>
           </p:nvPr>
         </p:nvSpPr>
         <p:spPr/>
@@ -3133,90 +3125,8 @@
           <a:bodyPr/>
           <a:lstStyle/>
           <a:p>
-            <a:pPr>
-              <a:defRPr sz="1800"/>
-            </a:pPr>
             <a:r>
               <a:t>Qishloq xo'jaligi uchun Coverage Path Planning</a:t>
-            </a:r>
-          </a:p>
-          <a:p>
-            <a:pPr lvl="1">
-              <a:defRPr sz="1600"/>
-            </a:pPr>
-            <a:r>
-              <a:t>Interaktiv dala va to'siq rejalashtirish</a:t>
-            </a:r>
-          </a:p>
-        </p:txBody>
-      </p:sp>
-    </p:spTree>
-  </p:cSld>
-  <p:clrMapOvr>
-    <a:masterClrMapping/>
-  </p:clrMapOvr>
-</p:sld>
-</file>
-
-<file path=ppt/slides/slide10.xml><?xml version="1.0" encoding="utf-8"?>
-<p:sld xmlns:a="http://schemas.openxmlformats.org/drawingml/2006/main" xmlns:p="http://schemas.openxmlformats.org/presentationml/2006/main" xmlns:r="http://schemas.openxmlformats.org/officeDocument/2006/relationships">
-  <p:cSld>
-    <p:spTree>
-      <p:nvGrpSpPr>
-        <p:cNvPr id="1" name=""/>
-        <p:cNvGrpSpPr/>
-        <p:nvPr/>
-      </p:nvGrpSpPr>
-      <p:grpSpPr/>
-      <p:sp>
-        <p:nvSpPr>
-          <p:cNvPr id="2" name="Title 1"/>
-          <p:cNvSpPr>
-            <a:spLocks noGrp="1"/>
-          </p:cNvSpPr>
-          <p:nvPr>
-            <p:ph type="title"/>
-          </p:nvPr>
-        </p:nvSpPr>
-        <p:spPr/>
-        <p:txBody>
-          <a:bodyPr/>
-          <a:lstStyle/>
-          <a:p>
-            <a:r>
-              <a:t>Kontakt</a:t>
-            </a:r>
-          </a:p>
-        </p:txBody>
-      </p:sp>
-      <p:sp>
-        <p:nvSpPr>
-          <p:cNvPr id="3" name="Content Placeholder 2"/>
-          <p:cNvSpPr>
-            <a:spLocks noGrp="1"/>
-          </p:cNvSpPr>
-          <p:nvPr>
-            <p:ph idx="1"/>
-          </p:nvPr>
-        </p:nvSpPr>
-        <p:spPr/>
-        <p:txBody>
-          <a:bodyPr/>
-          <a:lstStyle/>
-          <a:p>
-            <a:pPr>
-              <a:defRPr sz="1800"/>
-            </a:pPr>
-            <a:r>
-              <a:t>Repository: https://github.com/Nameless-devv/aziz</a:t>
-            </a:r>
-          </a:p>
-          <a:p>
-            <a:pPr lvl="1">
-              <a:defRPr sz="1600"/>
-            </a:pPr>
-            <a:r>
-              <a:t>Muallif: Sanjarbek / Nameless-devv</a:t>
             </a:r>
           </a:p>
         </p:txBody>
@@ -3241,19 +3151,111 @@
       <p:grpSpPr/>
       <p:sp>
         <p:nvSpPr>
-          <p:cNvPr id="2" name="Title 1"/>
-          <p:cNvSpPr>
-            <a:spLocks noGrp="1"/>
-          </p:cNvSpPr>
-          <p:nvPr>
-            <p:ph type="title"/>
-          </p:nvPr>
-        </p:nvSpPr>
-        <p:spPr/>
-        <p:txBody>
-          <a:bodyPr/>
-          <a:lstStyle/>
-          <a:p>
+          <p:cNvPr id="2" name="Rectangle 1"/>
+          <p:cNvSpPr/>
+          <p:nvPr/>
+        </p:nvSpPr>
+        <p:spPr>
+          <a:xfrm>
+            <a:off x="0" y="0"/>
+            <a:ext cx="9144000" cy="548640"/>
+          </a:xfrm>
+          <a:prstGeom prst="rect">
+            <a:avLst/>
+          </a:prstGeom>
+          <a:solidFill>
+            <a:srgbClr val="182C43"/>
+          </a:solidFill>
+          <a:ln>
+            <a:noFill/>
+          </a:ln>
+        </p:spPr>
+        <p:style>
+          <a:lnRef idx="1">
+            <a:schemeClr val="accent1"/>
+          </a:lnRef>
+          <a:fillRef idx="3">
+            <a:schemeClr val="accent1"/>
+          </a:fillRef>
+          <a:effectRef idx="2">
+            <a:schemeClr val="accent1"/>
+          </a:effectRef>
+          <a:fontRef idx="minor">
+            <a:schemeClr val="lt1"/>
+          </a:fontRef>
+        </p:style>
+        <p:txBody>
+          <a:bodyPr rtlCol="0" anchor="ctr"/>
+          <a:lstStyle/>
+          <a:p>
+            <a:pPr algn="ctr"/>
+          </a:p>
+        </p:txBody>
+      </p:sp>
+      <p:sp>
+        <p:nvSpPr>
+          <p:cNvPr id="3" name="TextBox 2"/>
+          <p:cNvSpPr txBox="1"/>
+          <p:nvPr/>
+        </p:nvSpPr>
+        <p:spPr>
+          <a:xfrm>
+            <a:off x="182880" y="109728"/>
+            <a:ext cx="1463040" cy="329184"/>
+          </a:xfrm>
+          <a:prstGeom prst="rect">
+            <a:avLst/>
+          </a:prstGeom>
+          <a:noFill/>
+        </p:spPr>
+        <p:txBody>
+          <a:bodyPr wrap="none">
+            <a:spAutoFit/>
+          </a:bodyPr>
+          <a:lstStyle/>
+          <a:p>
+            <a:pPr>
+              <a:defRPr sz="1200" b="1">
+                <a:solidFill>
+                  <a:srgbClr val="DCE6F0"/>
+                </a:solidFill>
+              </a:defRPr>
+            </a:pPr>
+            <a:r>
+              <a:t>Kirish</a:t>
+            </a:r>
+          </a:p>
+        </p:txBody>
+      </p:sp>
+      <p:sp>
+        <p:nvSpPr>
+          <p:cNvPr id="4" name="TextBox 3"/>
+          <p:cNvSpPr txBox="1"/>
+          <p:nvPr/>
+        </p:nvSpPr>
+        <p:spPr>
+          <a:xfrm>
+            <a:off x="1280160" y="109728"/>
+            <a:ext cx="1463040" cy="329184"/>
+          </a:xfrm>
+          <a:prstGeom prst="rect">
+            <a:avLst/>
+          </a:prstGeom>
+          <a:noFill/>
+        </p:spPr>
+        <p:txBody>
+          <a:bodyPr wrap="none">
+            <a:spAutoFit/>
+          </a:bodyPr>
+          <a:lstStyle/>
+          <a:p>
+            <a:pPr>
+              <a:defRPr sz="1200" b="1">
+                <a:solidFill>
+                  <a:srgbClr val="DCE6F0"/>
+                </a:solidFill>
+              </a:defRPr>
+            </a:pPr>
             <a:r>
               <a:t>Muammo</a:t>
             </a:r>
@@ -3262,593 +3264,510 @@
       </p:sp>
       <p:sp>
         <p:nvSpPr>
-          <p:cNvPr id="3" name="Content Placeholder 2"/>
-          <p:cNvSpPr>
-            <a:spLocks noGrp="1"/>
-          </p:cNvSpPr>
-          <p:nvPr>
-            <p:ph idx="1"/>
-          </p:nvPr>
-        </p:nvSpPr>
-        <p:spPr/>
-        <p:txBody>
-          <a:bodyPr/>
+          <p:cNvPr id="5" name="TextBox 4"/>
+          <p:cNvSpPr txBox="1"/>
+          <p:nvPr/>
+        </p:nvSpPr>
+        <p:spPr>
+          <a:xfrm>
+            <a:off x="2377440" y="109728"/>
+            <a:ext cx="1463040" cy="329184"/>
+          </a:xfrm>
+          <a:prstGeom prst="rect">
+            <a:avLst/>
+          </a:prstGeom>
+          <a:noFill/>
+        </p:spPr>
+        <p:txBody>
+          <a:bodyPr wrap="none">
+            <a:spAutoFit/>
+          </a:bodyPr>
           <a:lstStyle/>
           <a:p>
             <a:pPr>
-              <a:defRPr sz="1800"/>
+              <a:defRPr sz="1200" b="1">
+                <a:solidFill>
+                  <a:srgbClr val="DCE6F0"/>
+                </a:solidFill>
+              </a:defRPr>
             </a:pPr>
             <a:r>
-              <a:t>Maydon va to'siqlarni vizual tarzda chizish qiyin</a:t>
+              <a:t>Yechim</a:t>
+            </a:r>
+          </a:p>
+        </p:txBody>
+      </p:sp>
+      <p:sp>
+        <p:nvSpPr>
+          <p:cNvPr id="6" name="TextBox 5"/>
+          <p:cNvSpPr txBox="1"/>
+          <p:nvPr/>
+        </p:nvSpPr>
+        <p:spPr>
+          <a:xfrm>
+            <a:off x="3474720" y="109728"/>
+            <a:ext cx="1463040" cy="329184"/>
+          </a:xfrm>
+          <a:prstGeom prst="rect">
+            <a:avLst/>
+          </a:prstGeom>
+          <a:noFill/>
+        </p:spPr>
+        <p:txBody>
+          <a:bodyPr wrap="none">
+            <a:spAutoFit/>
+          </a:bodyPr>
+          <a:lstStyle/>
+          <a:p>
+            <a:pPr>
+              <a:defRPr sz="1200" b="1">
+                <a:solidFill>
+                  <a:srgbClr val="DCE6F0"/>
+                </a:solidFill>
+              </a:defRPr>
+            </a:pPr>
+            <a:r>
+              <a:t>Qanday ishlaydi</a:t>
+            </a:r>
+          </a:p>
+        </p:txBody>
+      </p:sp>
+      <p:sp>
+        <p:nvSpPr>
+          <p:cNvPr id="7" name="TextBox 6"/>
+          <p:cNvSpPr txBox="1"/>
+          <p:nvPr/>
+        </p:nvSpPr>
+        <p:spPr>
+          <a:xfrm>
+            <a:off x="4572000" y="109728"/>
+            <a:ext cx="1463040" cy="329184"/>
+          </a:xfrm>
+          <a:prstGeom prst="rect">
+            <a:avLst/>
+          </a:prstGeom>
+          <a:noFill/>
+        </p:spPr>
+        <p:txBody>
+          <a:bodyPr wrap="none">
+            <a:spAutoFit/>
+          </a:bodyPr>
+          <a:lstStyle/>
+          <a:p>
+            <a:pPr>
+              <a:defRPr sz="1200" b="1">
+                <a:solidFill>
+                  <a:srgbClr val="FF8A33"/>
+                </a:solidFill>
+              </a:defRPr>
+            </a:pPr>
+            <a:r>
+              <a:t>Natijalar</a:t>
+            </a:r>
+          </a:p>
+        </p:txBody>
+      </p:sp>
+      <p:sp>
+        <p:nvSpPr>
+          <p:cNvPr id="8" name="TextBox 7"/>
+          <p:cNvSpPr txBox="1"/>
+          <p:nvPr/>
+        </p:nvSpPr>
+        <p:spPr>
+          <a:xfrm>
+            <a:off x="5669280" y="109728"/>
+            <a:ext cx="1463040" cy="329184"/>
+          </a:xfrm>
+          <a:prstGeom prst="rect">
+            <a:avLst/>
+          </a:prstGeom>
+          <a:noFill/>
+        </p:spPr>
+        <p:txBody>
+          <a:bodyPr wrap="none">
+            <a:spAutoFit/>
+          </a:bodyPr>
+          <a:lstStyle/>
+          <a:p>
+            <a:pPr>
+              <a:defRPr sz="1200" b="1">
+                <a:solidFill>
+                  <a:srgbClr val="DCE6F0"/>
+                </a:solidFill>
+              </a:defRPr>
+            </a:pPr>
+            <a:r>
+              <a:t>Qo'llanish</a:t>
+            </a:r>
+          </a:p>
+        </p:txBody>
+      </p:sp>
+      <p:sp>
+        <p:nvSpPr>
+          <p:cNvPr id="9" name="TextBox 8"/>
+          <p:cNvSpPr txBox="1"/>
+          <p:nvPr/>
+        </p:nvSpPr>
+        <p:spPr>
+          <a:xfrm>
+            <a:off x="6766560" y="109728"/>
+            <a:ext cx="1463040" cy="329184"/>
+          </a:xfrm>
+          <a:prstGeom prst="rect">
+            <a:avLst/>
+          </a:prstGeom>
+          <a:noFill/>
+        </p:spPr>
+        <p:txBody>
+          <a:bodyPr wrap="none">
+            <a:spAutoFit/>
+          </a:bodyPr>
+          <a:lstStyle/>
+          <a:p>
+            <a:pPr>
+              <a:defRPr sz="1200" b="1">
+                <a:solidFill>
+                  <a:srgbClr val="DCE6F0"/>
+                </a:solidFill>
+              </a:defRPr>
+            </a:pPr>
+            <a:r>
+              <a:t>Xulosa</a:t>
+            </a:r>
+          </a:p>
+        </p:txBody>
+      </p:sp>
+      <p:pic>
+        <p:nvPicPr>
+          <p:cNvPr id="10" name="Picture 9" descr="_tmp_chart.png"/>
+          <p:cNvPicPr>
+            <a:picLocks noChangeAspect="1"/>
+          </p:cNvPicPr>
+          <p:nvPr/>
+        </p:nvPicPr>
+        <p:blipFill>
+          <a:blip r:embed="rId2"/>
+          <a:stretch>
+            <a:fillRect/>
+          </a:stretch>
+        </p:blipFill>
+        <p:spPr>
+          <a:xfrm>
+            <a:off x="548640" y="914400"/>
+            <a:ext cx="5943600" cy="3840480"/>
+          </a:xfrm>
+          <a:prstGeom prst="rect">
+            <a:avLst/>
+          </a:prstGeom>
+        </p:spPr>
+      </p:pic>
+      <p:sp>
+        <p:nvSpPr>
+          <p:cNvPr id="11" name="Rounded Rectangle 10"/>
+          <p:cNvSpPr/>
+          <p:nvPr/>
+        </p:nvSpPr>
+        <p:spPr>
+          <a:xfrm>
+            <a:off x="6766560" y="914400"/>
+            <a:ext cx="2743200" cy="548640"/>
+          </a:xfrm>
+          <a:prstGeom prst="roundRect">
+            <a:avLst/>
+          </a:prstGeom>
+          <a:solidFill>
+            <a:srgbClr val="F2F6F9"/>
+          </a:solidFill>
+          <a:ln>
+            <a:solidFill>
+              <a:srgbClr val="E1E6EB"/>
+            </a:solidFill>
+          </a:ln>
+        </p:spPr>
+        <p:style>
+          <a:lnRef idx="1">
+            <a:schemeClr val="accent1"/>
+          </a:lnRef>
+          <a:fillRef idx="3">
+            <a:schemeClr val="accent1"/>
+          </a:fillRef>
+          <a:effectRef idx="2">
+            <a:schemeClr val="accent1"/>
+          </a:effectRef>
+          <a:fontRef idx="minor">
+            <a:schemeClr val="lt1"/>
+          </a:fontRef>
+        </p:style>
+        <p:txBody>
+          <a:bodyPr rtlCol="0" anchor="ctr" lIns="101600"/>
+          <a:lstStyle/>
+          <a:p>
+            <a:pPr algn="ctr">
+              <a:defRPr sz="1200" b="1">
+                <a:solidFill>
+                  <a:srgbClr val="182C43"/>
+                </a:solidFill>
+              </a:defRPr>
+            </a:pPr>
+            <a:r>
+              <a:t>SVD va PCA</a:t>
             </a:r>
           </a:p>
           <a:p>
             <a:pPr lvl="1">
-              <a:defRPr sz="1600"/>
+              <a:defRPr sz="1000">
+                <a:solidFill>
+                  <a:srgbClr val="505A64"/>
+                </a:solidFill>
+              </a:defRPr>
             </a:pPr>
             <a:r>
-              <a:t>Robot uchun to'liq qoplama yo'llarini avtomatik yaratish kerak</a:t>
-            </a:r>
-          </a:p>
-        </p:txBody>
-      </p:sp>
-    </p:spTree>
-  </p:cSld>
-  <p:clrMapOvr>
-    <a:masterClrMapping/>
-  </p:clrMapOvr>
-</p:sld>
-</file>
-
-<file path=ppt/slides/slide3.xml><?xml version="1.0" encoding="utf-8"?>
-<p:sld xmlns:a="http://schemas.openxmlformats.org/drawingml/2006/main" xmlns:p="http://schemas.openxmlformats.org/presentationml/2006/main" xmlns:r="http://schemas.openxmlformats.org/officeDocument/2006/relationships">
-  <p:cSld>
-    <p:spTree>
-      <p:nvGrpSpPr>
-        <p:cNvPr id="1" name=""/>
-        <p:cNvGrpSpPr/>
-        <p:nvPr/>
-      </p:nvGrpSpPr>
-      <p:grpSpPr/>
-      <p:sp>
-        <p:nvSpPr>
-          <p:cNvPr id="2" name="Title 1"/>
-          <p:cNvSpPr>
-            <a:spLocks noGrp="1"/>
-          </p:cNvSpPr>
-          <p:nvPr>
-            <p:ph type="title"/>
-          </p:nvPr>
-        </p:nvSpPr>
-        <p:spPr/>
-        <p:txBody>
-          <a:bodyPr/>
-          <a:lstStyle/>
-          <a:p>
-            <a:r>
-              <a:t>Yechim</a:t>
-            </a:r>
-          </a:p>
-        </p:txBody>
-      </p:sp>
-      <p:sp>
-        <p:nvSpPr>
-          <p:cNvPr id="3" name="Content Placeholder 2"/>
-          <p:cNvSpPr>
-            <a:spLocks noGrp="1"/>
-          </p:cNvSpPr>
-          <p:nvPr>
-            <p:ph idx="1"/>
-          </p:nvPr>
-        </p:nvSpPr>
-        <p:spPr/>
-        <p:txBody>
-          <a:bodyPr/>
-          <a:lstStyle/>
-          <a:p>
-            <a:pPr>
-              <a:defRPr sz="1800"/>
+              <a:t>Eng eski matematik usullar. Ozgina yaxshi, lekin kam.</a:t>
+            </a:r>
+          </a:p>
+        </p:txBody>
+      </p:sp>
+      <p:sp>
+        <p:nvSpPr>
+          <p:cNvPr id="12" name="Rounded Rectangle 11"/>
+          <p:cNvSpPr/>
+          <p:nvPr/>
+        </p:nvSpPr>
+        <p:spPr>
+          <a:xfrm>
+            <a:off x="6766560" y="1627632"/>
+            <a:ext cx="2743200" cy="548640"/>
+          </a:xfrm>
+          <a:prstGeom prst="roundRect">
+            <a:avLst/>
+          </a:prstGeom>
+          <a:solidFill>
+            <a:srgbClr val="F2F6F9"/>
+          </a:solidFill>
+          <a:ln>
+            <a:solidFill>
+              <a:srgbClr val="E1E6EB"/>
+            </a:solidFill>
+          </a:ln>
+        </p:spPr>
+        <p:style>
+          <a:lnRef idx="1">
+            <a:schemeClr val="accent1"/>
+          </a:lnRef>
+          <a:fillRef idx="3">
+            <a:schemeClr val="accent1"/>
+          </a:fillRef>
+          <a:effectRef idx="2">
+            <a:schemeClr val="accent1"/>
+          </a:effectRef>
+          <a:fontRef idx="minor">
+            <a:schemeClr val="lt1"/>
+          </a:fontRef>
+        </p:style>
+        <p:txBody>
+          <a:bodyPr rtlCol="0" anchor="ctr" lIns="101600"/>
+          <a:lstStyle/>
+          <a:p>
+            <a:pPr algn="ctr">
+              <a:defRPr sz="1200" b="1">
+                <a:solidFill>
+                  <a:srgbClr val="182C43"/>
+                </a:solidFill>
+              </a:defRPr>
             </a:pPr>
             <a:r>
-              <a:t>Interaktiv matplotlib GUI (maydon + to'siq)</a:t>
+              <a:t>Wavelet</a:t>
             </a:r>
           </a:p>
           <a:p>
             <a:pPr lvl="1">
-              <a:defRPr sz="1600"/>
+              <a:defRPr sz="1000">
+                <a:solidFill>
+                  <a:srgbClr val="505A64"/>
+                </a:solidFill>
+              </a:defRPr>
             </a:pPr>
             <a:r>
-              <a:t>Boustrophedon va spiral coverage algoritmlari</a:t>
+              <a:t>Yaxshi usul. Klinikada ishlatiladi. Lekin AI dan past.</a:t>
+            </a:r>
+          </a:p>
+        </p:txBody>
+      </p:sp>
+      <p:sp>
+        <p:nvSpPr>
+          <p:cNvPr id="13" name="Rounded Rectangle 12"/>
+          <p:cNvSpPr/>
+          <p:nvPr/>
+        </p:nvSpPr>
+        <p:spPr>
+          <a:xfrm>
+            <a:off x="6766560" y="2340864"/>
+            <a:ext cx="2743200" cy="548640"/>
+          </a:xfrm>
+          <a:prstGeom prst="roundRect">
+            <a:avLst/>
+          </a:prstGeom>
+          <a:solidFill>
+            <a:srgbClr val="F2F6F9"/>
+          </a:solidFill>
+          <a:ln>
+            <a:solidFill>
+              <a:srgbClr val="E1E6EB"/>
+            </a:solidFill>
+          </a:ln>
+        </p:spPr>
+        <p:style>
+          <a:lnRef idx="1">
+            <a:schemeClr val="accent1"/>
+          </a:lnRef>
+          <a:fillRef idx="3">
+            <a:schemeClr val="accent1"/>
+          </a:fillRef>
+          <a:effectRef idx="2">
+            <a:schemeClr val="accent1"/>
+          </a:effectRef>
+          <a:fontRef idx="minor">
+            <a:schemeClr val="lt1"/>
+          </a:fontRef>
+        </p:style>
+        <p:txBody>
+          <a:bodyPr rtlCol="0" anchor="ctr" lIns="101600"/>
+          <a:lstStyle/>
+          <a:p>
+            <a:pPr algn="ctr">
+              <a:defRPr sz="1200" b="1">
+                <a:solidFill>
+                  <a:srgbClr val="182C43"/>
+                </a:solidFill>
+              </a:defRPr>
+            </a:pPr>
+            <a:r>
+              <a:t>Autoencoder</a:t>
             </a:r>
           </a:p>
           <a:p>
             <a:pPr lvl="1">
-              <a:defRPr sz="1600"/>
+              <a:defRPr sz="1000">
+                <a:solidFill>
+                  <a:srgbClr val="505A64"/>
+                </a:solidFill>
+              </a:defRPr>
             </a:pPr>
             <a:r>
-              <a:t>Portativ o'rnatish - `aziz` buyruqi</a:t>
-            </a:r>
-          </a:p>
-        </p:txBody>
-      </p:sp>
-    </p:spTree>
-  </p:cSld>
-  <p:clrMapOvr>
-    <a:masterClrMapping/>
-  </p:clrMapOvr>
-</p:sld>
-</file>
-
-<file path=ppt/slides/slide4.xml><?xml version="1.0" encoding="utf-8"?>
-<p:sld xmlns:a="http://schemas.openxmlformats.org/drawingml/2006/main" xmlns:p="http://schemas.openxmlformats.org/presentationml/2006/main" xmlns:r="http://schemas.openxmlformats.org/officeDocument/2006/relationships">
-  <p:cSld>
-    <p:spTree>
-      <p:nvGrpSpPr>
-        <p:cNvPr id="1" name=""/>
-        <p:cNvGrpSpPr/>
-        <p:nvPr/>
-      </p:nvGrpSpPr>
-      <p:grpSpPr/>
-      <p:sp>
-        <p:nvSpPr>
-          <p:cNvPr id="2" name="Title 1"/>
-          <p:cNvSpPr>
-            <a:spLocks noGrp="1"/>
-          </p:cNvSpPr>
-          <p:nvPr>
-            <p:ph type="title"/>
-          </p:nvPr>
-        </p:nvSpPr>
-        <p:spPr/>
-        <p:txBody>
-          <a:bodyPr/>
-          <a:lstStyle/>
-          <a:p>
-            <a:r>
-              <a:t>Arxitektura</a:t>
-            </a:r>
-          </a:p>
-        </p:txBody>
-      </p:sp>
-      <p:sp>
-        <p:nvSpPr>
-          <p:cNvPr id="3" name="Content Placeholder 2"/>
-          <p:cNvSpPr>
-            <a:spLocks noGrp="1"/>
-          </p:cNvSpPr>
-          <p:nvPr>
-            <p:ph idx="1"/>
-          </p:nvPr>
-        </p:nvSpPr>
-        <p:spPr/>
-        <p:txBody>
-          <a:bodyPr/>
-          <a:lstStyle/>
-          <a:p>
-            <a:pPr>
-              <a:defRPr sz="1800"/>
+              <a:t>AI usuli. Wavelet dan sezilarli darajada yaxshiroq.</a:t>
+            </a:r>
+          </a:p>
+        </p:txBody>
+      </p:sp>
+      <p:sp>
+        <p:nvSpPr>
+          <p:cNvPr id="14" name="Rounded Rectangle 13"/>
+          <p:cNvSpPr/>
+          <p:nvPr/>
+        </p:nvSpPr>
+        <p:spPr>
+          <a:xfrm>
+            <a:off x="6766560" y="3054096"/>
+            <a:ext cx="2743200" cy="548640"/>
+          </a:xfrm>
+          <a:prstGeom prst="roundRect">
+            <a:avLst/>
+          </a:prstGeom>
+          <a:solidFill>
+            <a:srgbClr val="F2F6F9"/>
+          </a:solidFill>
+          <a:ln>
+            <a:solidFill>
+              <a:srgbClr val="E1E6EB"/>
+            </a:solidFill>
+          </a:ln>
+        </p:spPr>
+        <p:style>
+          <a:lnRef idx="1">
+            <a:schemeClr val="accent1"/>
+          </a:lnRef>
+          <a:fillRef idx="3">
+            <a:schemeClr val="accent1"/>
+          </a:fillRef>
+          <a:effectRef idx="2">
+            <a:schemeClr val="accent1"/>
+          </a:effectRef>
+          <a:fontRef idx="minor">
+            <a:schemeClr val="lt1"/>
+          </a:fontRef>
+        </p:style>
+        <p:txBody>
+          <a:bodyPr rtlCol="0" anchor="ctr" lIns="101600"/>
+          <a:lstStyle/>
+          <a:p>
+            <a:pPr algn="ctr">
+              <a:defRPr sz="1200" b="1">
+                <a:solidFill>
+                  <a:srgbClr val="182C43"/>
+                </a:solidFill>
+              </a:defRPr>
             </a:pPr>
             <a:r>
-              <a:t>`robo.py` - GUI entrypoint</a:t>
+              <a:t>U-Net — G'olib!</a:t>
             </a:r>
           </a:p>
           <a:p>
             <a:pPr lvl="1">
-              <a:defRPr sz="1600"/>
+              <a:defRPr sz="1000">
+                <a:solidFill>
+                  <a:srgbClr val="505A64"/>
+                </a:solidFill>
+              </a:defRPr>
             </a:pPr>
             <a:r>
-              <a:t>`src/environment_modeling.py` - maydon va to'siq modellari</a:t>
-            </a:r>
-          </a:p>
-          <a:p>
-            <a:pPr lvl="1">
-              <a:defRPr sz="1600"/>
-            </a:pPr>
-            <a:r>
-              <a:t>`src/coverage_planning.py` - coverage algoritmlari</a:t>
-            </a:r>
-          </a:p>
-        </p:txBody>
-      </p:sp>
-    </p:spTree>
-  </p:cSld>
-  <p:clrMapOvr>
-    <a:masterClrMapping/>
-  </p:clrMapOvr>
-</p:sld>
-</file>
-
-<file path=ppt/slides/slide5.xml><?xml version="1.0" encoding="utf-8"?>
-<p:sld xmlns:a="http://schemas.openxmlformats.org/drawingml/2006/main" xmlns:p="http://schemas.openxmlformats.org/presentationml/2006/main" xmlns:r="http://schemas.openxmlformats.org/officeDocument/2006/relationships">
-  <p:cSld>
-    <p:spTree>
-      <p:nvGrpSpPr>
-        <p:cNvPr id="1" name=""/>
-        <p:cNvGrpSpPr/>
-        <p:nvPr/>
-      </p:nvGrpSpPr>
-      <p:grpSpPr/>
-      <p:sp>
-        <p:nvSpPr>
-          <p:cNvPr id="2" name="Title 1"/>
-          <p:cNvSpPr>
-            <a:spLocks noGrp="1"/>
-          </p:cNvSpPr>
-          <p:nvPr>
-            <p:ph type="title"/>
-          </p:nvPr>
-        </p:nvSpPr>
-        <p:spPr/>
-        <p:txBody>
-          <a:bodyPr/>
-          <a:lstStyle/>
-          <a:p>
-            <a:r>
-              <a:t>Modullar va Funksiyalar</a:t>
-            </a:r>
-          </a:p>
-        </p:txBody>
-      </p:sp>
-      <p:sp>
-        <p:nvSpPr>
-          <p:cNvPr id="3" name="Content Placeholder 2"/>
-          <p:cNvSpPr>
-            <a:spLocks noGrp="1"/>
-          </p:cNvSpPr>
-          <p:nvPr>
-            <p:ph idx="1"/>
-          </p:nvPr>
-        </p:nvSpPr>
-        <p:spPr/>
-        <p:txBody>
-          <a:bodyPr/>
-          <a:lstStyle/>
-          <a:p>
-            <a:pPr>
-              <a:defRPr sz="1800"/>
-            </a:pPr>
-            <a:r>
-              <a:t>Field yaratish va to'siq qo'shish</a:t>
-            </a:r>
-          </a:p>
-          <a:p>
-            <a:pPr lvl="1">
-              <a:defRPr sz="1600"/>
-            </a:pPr>
-            <a:r>
-              <a:t>Planner: CoveragePathPlanner</a:t>
-            </a:r>
-          </a:p>
-          <a:p>
-            <a:pPr lvl="1">
-              <a:defRPr sz="1600"/>
-            </a:pPr>
-            <a:r>
-              <a:t>Vizualizatsiya: matplotlib</a:t>
-            </a:r>
-          </a:p>
-        </p:txBody>
-      </p:sp>
-    </p:spTree>
-  </p:cSld>
-  <p:clrMapOvr>
-    <a:masterClrMapping/>
-  </p:clrMapOvr>
-</p:sld>
-</file>
-
-<file path=ppt/slides/slide6.xml><?xml version="1.0" encoding="utf-8"?>
-<p:sld xmlns:a="http://schemas.openxmlformats.org/drawingml/2006/main" xmlns:p="http://schemas.openxmlformats.org/presentationml/2006/main" xmlns:r="http://schemas.openxmlformats.org/officeDocument/2006/relationships">
-  <p:cSld>
-    <p:spTree>
-      <p:nvGrpSpPr>
-        <p:cNvPr id="1" name=""/>
-        <p:cNvGrpSpPr/>
-        <p:nvPr/>
-      </p:nvGrpSpPr>
-      <p:grpSpPr/>
-      <p:sp>
-        <p:nvSpPr>
-          <p:cNvPr id="2" name="Title 1"/>
-          <p:cNvSpPr>
-            <a:spLocks noGrp="1"/>
-          </p:cNvSpPr>
-          <p:nvPr>
-            <p:ph type="title"/>
-          </p:nvPr>
-        </p:nvSpPr>
-        <p:spPr/>
-        <p:txBody>
-          <a:bodyPr/>
-          <a:lstStyle/>
-          <a:p>
-            <a:r>
-              <a:t>O'rnatish va Ishga tushirish</a:t>
-            </a:r>
-          </a:p>
-        </p:txBody>
-      </p:sp>
-      <p:sp>
-        <p:nvSpPr>
-          <p:cNvPr id="3" name="Content Placeholder 2"/>
-          <p:cNvSpPr>
-            <a:spLocks noGrp="1"/>
-          </p:cNvSpPr>
-          <p:nvPr>
-            <p:ph idx="1"/>
-          </p:nvPr>
-        </p:nvSpPr>
-        <p:spPr/>
-        <p:txBody>
-          <a:bodyPr/>
-          <a:lstStyle/>
-          <a:p>
-            <a:pPr>
-              <a:defRPr sz="1800"/>
-            </a:pPr>
-            <a:r>
-              <a:t>git clone https://github.com/Nameless-devv/aziz.git</a:t>
-            </a:r>
-          </a:p>
-          <a:p>
-            <a:pPr lvl="1">
-              <a:defRPr sz="1600"/>
-            </a:pPr>
-            <a:r>
-              <a:t>bash install.sh  (macOS/Linux)</a:t>
-            </a:r>
-          </a:p>
-          <a:p>
-            <a:pPr lvl="1">
-              <a:defRPr sz="1600"/>
-            </a:pPr>
-            <a:r>
-              <a:t>install.bat yoki .\install.ps1 (Windows)</a:t>
-            </a:r>
-          </a:p>
-          <a:p>
-            <a:pPr lvl="1">
-              <a:defRPr sz="1600"/>
-            </a:pPr>
-            <a:r>
-              <a:t>aziz  — dastur ishga tushadi</a:t>
-            </a:r>
-          </a:p>
-        </p:txBody>
-      </p:sp>
-    </p:spTree>
-  </p:cSld>
-  <p:clrMapOvr>
-    <a:masterClrMapping/>
-  </p:clrMapOvr>
-</p:sld>
-</file>
-
-<file path=ppt/slides/slide7.xml><?xml version="1.0" encoding="utf-8"?>
-<p:sld xmlns:a="http://schemas.openxmlformats.org/drawingml/2006/main" xmlns:p="http://schemas.openxmlformats.org/presentationml/2006/main" xmlns:r="http://schemas.openxmlformats.org/officeDocument/2006/relationships">
-  <p:cSld>
-    <p:spTree>
-      <p:nvGrpSpPr>
-        <p:cNvPr id="1" name=""/>
-        <p:cNvGrpSpPr/>
-        <p:nvPr/>
-      </p:nvGrpSpPr>
-      <p:grpSpPr/>
-      <p:sp>
-        <p:nvSpPr>
-          <p:cNvPr id="2" name="Title 1"/>
-          <p:cNvSpPr>
-            <a:spLocks noGrp="1"/>
-          </p:cNvSpPr>
-          <p:nvPr>
-            <p:ph type="title"/>
-          </p:nvPr>
-        </p:nvSpPr>
-        <p:spPr/>
-        <p:txBody>
-          <a:bodyPr/>
-          <a:lstStyle/>
-          <a:p>
-            <a:r>
-              <a:t>Demo va Ekranlar</a:t>
-            </a:r>
-          </a:p>
-        </p:txBody>
-      </p:sp>
-      <p:sp>
-        <p:nvSpPr>
-          <p:cNvPr id="3" name="Content Placeholder 2"/>
-          <p:cNvSpPr>
-            <a:spLocks noGrp="1"/>
-          </p:cNvSpPr>
-          <p:nvPr>
-            <p:ph idx="1"/>
-          </p:nvPr>
-        </p:nvSpPr>
-        <p:spPr/>
-        <p:txBody>
-          <a:bodyPr/>
-          <a:lstStyle/>
-          <a:p>
-            <a:pPr>
-              <a:defRPr sz="1800"/>
-            </a:pPr>
-            <a:r>
-              <a:t>Interaktiv maydon chizish</a:t>
-            </a:r>
-          </a:p>
-          <a:p>
-            <a:pPr lvl="1">
-              <a:defRPr sz="1600"/>
-            </a:pPr>
-            <a:r>
-              <a:t>To'siqlarni qo'shish</a:t>
-            </a:r>
-          </a:p>
-          <a:p>
-            <a:pPr lvl="1">
-              <a:defRPr sz="1600"/>
-            </a:pPr>
-            <a:r>
-              <a:t>Yo'lni rejalashtirish va vizualizatsiya</a:t>
-            </a:r>
-          </a:p>
-        </p:txBody>
-      </p:sp>
-    </p:spTree>
-  </p:cSld>
-  <p:clrMapOvr>
-    <a:masterClrMapping/>
-  </p:clrMapOvr>
-</p:sld>
-</file>
-
-<file path=ppt/slides/slide8.xml><?xml version="1.0" encoding="utf-8"?>
-<p:sld xmlns:a="http://schemas.openxmlformats.org/drawingml/2006/main" xmlns:p="http://schemas.openxmlformats.org/presentationml/2006/main" xmlns:r="http://schemas.openxmlformats.org/officeDocument/2006/relationships">
-  <p:cSld>
-    <p:spTree>
-      <p:nvGrpSpPr>
-        <p:cNvPr id="1" name=""/>
-        <p:cNvGrpSpPr/>
-        <p:nvPr/>
-      </p:nvGrpSpPr>
-      <p:grpSpPr/>
-      <p:sp>
-        <p:nvSpPr>
-          <p:cNvPr id="2" name="Title 1"/>
-          <p:cNvSpPr>
-            <a:spLocks noGrp="1"/>
-          </p:cNvSpPr>
-          <p:nvPr>
-            <p:ph type="title"/>
-          </p:nvPr>
-        </p:nvSpPr>
-        <p:spPr/>
-        <p:txBody>
-          <a:bodyPr/>
-          <a:lstStyle/>
-          <a:p>
-            <a:r>
-              <a:t>Natija va Foyda</a:t>
-            </a:r>
-          </a:p>
-        </p:txBody>
-      </p:sp>
-      <p:sp>
-        <p:nvSpPr>
-          <p:cNvPr id="3" name="Content Placeholder 2"/>
-          <p:cNvSpPr>
-            <a:spLocks noGrp="1"/>
-          </p:cNvSpPr>
-          <p:nvPr>
-            <p:ph idx="1"/>
-          </p:nvPr>
-        </p:nvSpPr>
-        <p:spPr/>
-        <p:txBody>
-          <a:bodyPr/>
-          <a:lstStyle/>
-          <a:p>
-            <a:pPr>
-              <a:defRPr sz="1800"/>
-            </a:pPr>
-            <a:r>
-              <a:t>Portativ va qayta o'rnatiluvchi loyiha</a:t>
-            </a:r>
-          </a:p>
-          <a:p>
-            <a:pPr lvl="1">
-              <a:defRPr sz="1600"/>
-            </a:pPr>
-            <a:r>
-              <a:t>Oson integratsiya boshqa tizimlarga</a:t>
-            </a:r>
-          </a:p>
-          <a:p>
-            <a:pPr lvl="1">
-              <a:defRPr sz="1600"/>
-            </a:pPr>
-            <a:r>
-              <a:t>Ta'lim va ilmiy ishlar uchun mos</a:t>
-            </a:r>
-          </a:p>
-        </p:txBody>
-      </p:sp>
-    </p:spTree>
-  </p:cSld>
-  <p:clrMapOvr>
-    <a:masterClrMapping/>
-  </p:clrMapOvr>
-</p:sld>
-</file>
-
-<file path=ppt/slides/slide9.xml><?xml version="1.0" encoding="utf-8"?>
-<p:sld xmlns:a="http://schemas.openxmlformats.org/drawingml/2006/main" xmlns:p="http://schemas.openxmlformats.org/presentationml/2006/main" xmlns:r="http://schemas.openxmlformats.org/officeDocument/2006/relationships">
-  <p:cSld>
-    <p:spTree>
-      <p:nvGrpSpPr>
-        <p:cNvPr id="1" name=""/>
-        <p:cNvGrpSpPr/>
-        <p:nvPr/>
-      </p:nvGrpSpPr>
-      <p:grpSpPr/>
-      <p:sp>
-        <p:nvSpPr>
-          <p:cNvPr id="2" name="Title 1"/>
-          <p:cNvSpPr>
-            <a:spLocks noGrp="1"/>
-          </p:cNvSpPr>
-          <p:nvPr>
-            <p:ph type="title"/>
-          </p:nvPr>
-        </p:nvSpPr>
-        <p:spPr/>
-        <p:txBody>
-          <a:bodyPr/>
-          <a:lstStyle/>
-          <a:p>
-            <a:r>
-              <a:t>Keyingi Qadamlar</a:t>
-            </a:r>
-          </a:p>
-        </p:txBody>
-      </p:sp>
-      <p:sp>
-        <p:nvSpPr>
-          <p:cNvPr id="3" name="Content Placeholder 2"/>
-          <p:cNvSpPr>
-            <a:spLocks noGrp="1"/>
-          </p:cNvSpPr>
-          <p:nvPr>
-            <p:ph idx="1"/>
-          </p:nvPr>
-        </p:nvSpPr>
-        <p:spPr/>
-        <p:txBody>
-          <a:bodyPr/>
-          <a:lstStyle/>
-          <a:p>
-            <a:pPr>
-              <a:defRPr sz="1800"/>
-            </a:pPr>
-            <a:r>
-              <a:t>Qo'shimcha algoritmlar</a:t>
-            </a:r>
-          </a:p>
-          <a:p>
-            <a:pPr lvl="1">
-              <a:defRPr sz="1600"/>
-            </a:pPr>
-            <a:r>
-              <a:t>ROS integratsiyasi</a:t>
-            </a:r>
-          </a:p>
-          <a:p>
-            <a:pPr lvl="1">
-              <a:defRPr sz="1600"/>
-            </a:pPr>
-            <a:r>
-              <a:t>Sensorlarni simulyatsiya qilish va testlar</a:t>
+              <a:t>Barcha shovqin turlarida eng yaxshi natija. 88% samaradorlik!</a:t>
+            </a:r>
+          </a:p>
+        </p:txBody>
+      </p:sp>
+      <p:sp>
+        <p:nvSpPr>
+          <p:cNvPr id="15" name="Rounded Rectangle 14"/>
+          <p:cNvSpPr/>
+          <p:nvPr/>
+        </p:nvSpPr>
+        <p:spPr>
+          <a:xfrm>
+            <a:off x="6766560" y="3858768"/>
+            <a:ext cx="2743200" cy="731520"/>
+          </a:xfrm>
+          <a:prstGeom prst="roundRect">
+            <a:avLst/>
+          </a:prstGeom>
+          <a:solidFill>
+            <a:srgbClr val="1C2636"/>
+          </a:solidFill>
+        </p:spPr>
+        <p:style>
+          <a:lnRef idx="1">
+            <a:schemeClr val="accent1"/>
+          </a:lnRef>
+          <a:fillRef idx="3">
+            <a:schemeClr val="accent1"/>
+          </a:fillRef>
+          <a:effectRef idx="2">
+            <a:schemeClr val="accent1"/>
+          </a:effectRef>
+          <a:fontRef idx="minor">
+            <a:schemeClr val="lt1"/>
+          </a:fontRef>
+        </p:style>
+        <p:txBody>
+          <a:bodyPr rtlCol="0" anchor="ctr"/>
+          <a:lstStyle/>
+          <a:p>
+            <a:r>
+              <a:rPr>
+                <a:solidFill>
+                  <a:srgbClr val="FFFFFF"/>
+                </a:solidFill>
+              </a:rPr>
+              <a:t>Xulosa: AI usullari (Autoencoder, U-Net) an'anaviy usullarga qaraganda yuqori samaradorlik ko'rsatadi.</a:t>
             </a:r>
           </a:p>
         </p:txBody>

</xml_diff>